<commit_message>
Week 9 and 10 touchups
</commit_message>
<xml_diff>
--- a/week10/ITP4Hexamguidelines.pptx
+++ b/week10/ITP4Hexamguidelines.pptx
@@ -111,6 +111,11 @@
       </a:defRPr>
     </a:lvl9pPr>
   </p:defaultTextStyle>
+  <p:extLst>
+    <p:ext uri="{EFAFB233-063F-42B5-8137-9DF3F51BA10A}">
+      <p15:sldGuideLst xmlns:p15="http://schemas.microsoft.com/office/powerpoint/2012/main"/>
+    </p:ext>
+  </p:extLst>
 </p:presentation>
 </file>
 
@@ -263,7 +268,7 @@
           <a:p>
             <a:fld id="{FDC2CD99-A805-4CE7-A5EE-300FD0C57595}" type="datetimeFigureOut">
               <a:rPr lang="en-US" smtClean="0"/>
-              <a:t>2/6/2025</a:t>
+              <a:t>12/13/2025</a:t>
             </a:fld>
             <a:endParaRPr lang="en-US"/>
           </a:p>
@@ -317,7 +322,7 @@
           <a:p>
             <a:fld id="{27F79AAA-5DB5-4C5E-894C-2399923A40A5}" type="slidenum">
               <a:rPr lang="en-US" smtClean="0"/>
-              <a:t>‹N›</a:t>
+              <a:t>‹#›</a:t>
             </a:fld>
             <a:endParaRPr lang="en-US"/>
           </a:p>
@@ -463,7 +468,7 @@
           <a:p>
             <a:fld id="{FDC2CD99-A805-4CE7-A5EE-300FD0C57595}" type="datetimeFigureOut">
               <a:rPr lang="en-US" smtClean="0"/>
-              <a:t>2/6/2025</a:t>
+              <a:t>12/13/2025</a:t>
             </a:fld>
             <a:endParaRPr lang="en-US"/>
           </a:p>
@@ -517,7 +522,7 @@
           <a:p>
             <a:fld id="{27F79AAA-5DB5-4C5E-894C-2399923A40A5}" type="slidenum">
               <a:rPr lang="en-US" smtClean="0"/>
-              <a:t>‹N›</a:t>
+              <a:t>‹#›</a:t>
             </a:fld>
             <a:endParaRPr lang="en-US"/>
           </a:p>
@@ -673,7 +678,7 @@
           <a:p>
             <a:fld id="{FDC2CD99-A805-4CE7-A5EE-300FD0C57595}" type="datetimeFigureOut">
               <a:rPr lang="en-US" smtClean="0"/>
-              <a:t>2/6/2025</a:t>
+              <a:t>12/13/2025</a:t>
             </a:fld>
             <a:endParaRPr lang="en-US"/>
           </a:p>
@@ -727,7 +732,7 @@
           <a:p>
             <a:fld id="{27F79AAA-5DB5-4C5E-894C-2399923A40A5}" type="slidenum">
               <a:rPr lang="en-US" smtClean="0"/>
-              <a:t>‹N›</a:t>
+              <a:t>‹#›</a:t>
             </a:fld>
             <a:endParaRPr lang="en-US"/>
           </a:p>
@@ -873,7 +878,7 @@
           <a:p>
             <a:fld id="{FDC2CD99-A805-4CE7-A5EE-300FD0C57595}" type="datetimeFigureOut">
               <a:rPr lang="en-US" smtClean="0"/>
-              <a:t>2/6/2025</a:t>
+              <a:t>12/13/2025</a:t>
             </a:fld>
             <a:endParaRPr lang="en-US"/>
           </a:p>
@@ -927,7 +932,7 @@
           <a:p>
             <a:fld id="{27F79AAA-5DB5-4C5E-894C-2399923A40A5}" type="slidenum">
               <a:rPr lang="en-US" smtClean="0"/>
-              <a:t>‹N›</a:t>
+              <a:t>‹#›</a:t>
             </a:fld>
             <a:endParaRPr lang="en-US"/>
           </a:p>
@@ -1149,7 +1154,7 @@
           <a:p>
             <a:fld id="{FDC2CD99-A805-4CE7-A5EE-300FD0C57595}" type="datetimeFigureOut">
               <a:rPr lang="en-US" smtClean="0"/>
-              <a:t>2/6/2025</a:t>
+              <a:t>12/13/2025</a:t>
             </a:fld>
             <a:endParaRPr lang="en-US"/>
           </a:p>
@@ -1203,7 +1208,7 @@
           <a:p>
             <a:fld id="{27F79AAA-5DB5-4C5E-894C-2399923A40A5}" type="slidenum">
               <a:rPr lang="en-US" smtClean="0"/>
-              <a:t>‹N›</a:t>
+              <a:t>‹#›</a:t>
             </a:fld>
             <a:endParaRPr lang="en-US"/>
           </a:p>
@@ -1417,7 +1422,7 @@
           <a:p>
             <a:fld id="{FDC2CD99-A805-4CE7-A5EE-300FD0C57595}" type="datetimeFigureOut">
               <a:rPr lang="en-US" smtClean="0"/>
-              <a:t>2/6/2025</a:t>
+              <a:t>12/13/2025</a:t>
             </a:fld>
             <a:endParaRPr lang="en-US"/>
           </a:p>
@@ -1471,7 +1476,7 @@
           <a:p>
             <a:fld id="{27F79AAA-5DB5-4C5E-894C-2399923A40A5}" type="slidenum">
               <a:rPr lang="en-US" smtClean="0"/>
-              <a:t>‹N›</a:t>
+              <a:t>‹#›</a:t>
             </a:fld>
             <a:endParaRPr lang="en-US"/>
           </a:p>
@@ -1832,7 +1837,7 @@
           <a:p>
             <a:fld id="{FDC2CD99-A805-4CE7-A5EE-300FD0C57595}" type="datetimeFigureOut">
               <a:rPr lang="en-US" smtClean="0"/>
-              <a:t>2/6/2025</a:t>
+              <a:t>12/13/2025</a:t>
             </a:fld>
             <a:endParaRPr lang="en-US"/>
           </a:p>
@@ -1886,7 +1891,7 @@
           <a:p>
             <a:fld id="{27F79AAA-5DB5-4C5E-894C-2399923A40A5}" type="slidenum">
               <a:rPr lang="en-US" smtClean="0"/>
-              <a:t>‹N›</a:t>
+              <a:t>‹#›</a:t>
             </a:fld>
             <a:endParaRPr lang="en-US"/>
           </a:p>
@@ -1974,7 +1979,7 @@
           <a:p>
             <a:fld id="{FDC2CD99-A805-4CE7-A5EE-300FD0C57595}" type="datetimeFigureOut">
               <a:rPr lang="en-US" smtClean="0"/>
-              <a:t>2/6/2025</a:t>
+              <a:t>12/13/2025</a:t>
             </a:fld>
             <a:endParaRPr lang="en-US"/>
           </a:p>
@@ -2028,7 +2033,7 @@
           <a:p>
             <a:fld id="{27F79AAA-5DB5-4C5E-894C-2399923A40A5}" type="slidenum">
               <a:rPr lang="en-US" smtClean="0"/>
-              <a:t>‹N›</a:t>
+              <a:t>‹#›</a:t>
             </a:fld>
             <a:endParaRPr lang="en-US"/>
           </a:p>
@@ -2087,7 +2092,7 @@
           <a:p>
             <a:fld id="{FDC2CD99-A805-4CE7-A5EE-300FD0C57595}" type="datetimeFigureOut">
               <a:rPr lang="en-US" smtClean="0"/>
-              <a:t>2/6/2025</a:t>
+              <a:t>12/13/2025</a:t>
             </a:fld>
             <a:endParaRPr lang="en-US"/>
           </a:p>
@@ -2141,7 +2146,7 @@
           <a:p>
             <a:fld id="{27F79AAA-5DB5-4C5E-894C-2399923A40A5}" type="slidenum">
               <a:rPr lang="en-US" smtClean="0"/>
-              <a:t>‹N›</a:t>
+              <a:t>‹#›</a:t>
             </a:fld>
             <a:endParaRPr lang="en-US"/>
           </a:p>
@@ -2400,7 +2405,7 @@
           <a:p>
             <a:fld id="{FDC2CD99-A805-4CE7-A5EE-300FD0C57595}" type="datetimeFigureOut">
               <a:rPr lang="en-US" smtClean="0"/>
-              <a:t>2/6/2025</a:t>
+              <a:t>12/13/2025</a:t>
             </a:fld>
             <a:endParaRPr lang="en-US"/>
           </a:p>
@@ -2454,7 +2459,7 @@
           <a:p>
             <a:fld id="{27F79AAA-5DB5-4C5E-894C-2399923A40A5}" type="slidenum">
               <a:rPr lang="en-US" smtClean="0"/>
-              <a:t>‹N›</a:t>
+              <a:t>‹#›</a:t>
             </a:fld>
             <a:endParaRPr lang="en-US"/>
           </a:p>
@@ -2689,7 +2694,7 @@
           <a:p>
             <a:fld id="{FDC2CD99-A805-4CE7-A5EE-300FD0C57595}" type="datetimeFigureOut">
               <a:rPr lang="en-US" smtClean="0"/>
-              <a:t>2/6/2025</a:t>
+              <a:t>12/13/2025</a:t>
             </a:fld>
             <a:endParaRPr lang="en-US"/>
           </a:p>
@@ -2743,7 +2748,7 @@
           <a:p>
             <a:fld id="{27F79AAA-5DB5-4C5E-894C-2399923A40A5}" type="slidenum">
               <a:rPr lang="en-US" smtClean="0"/>
-              <a:t>‹N›</a:t>
+              <a:t>‹#›</a:t>
             </a:fld>
             <a:endParaRPr lang="en-US"/>
           </a:p>
@@ -2932,7 +2937,7 @@
           <a:p>
             <a:fld id="{FDC2CD99-A805-4CE7-A5EE-300FD0C57595}" type="datetimeFigureOut">
               <a:rPr lang="en-US" smtClean="0"/>
-              <a:t>2/6/2025</a:t>
+              <a:t>12/13/2025</a:t>
             </a:fld>
             <a:endParaRPr lang="en-US"/>
           </a:p>
@@ -3022,7 +3027,7 @@
           <a:p>
             <a:fld id="{27F79AAA-5DB5-4C5E-894C-2399923A40A5}" type="slidenum">
               <a:rPr lang="en-US" smtClean="0"/>
-              <a:t>‹N›</a:t>
+              <a:t>‹#›</a:t>
             </a:fld>
             <a:endParaRPr lang="en-US"/>
           </a:p>
@@ -3415,31 +3420,17 @@
           <a:p>
             <a:r>
               <a:rPr lang="it-IT" dirty="0"/>
-              <a:t>Dr. Bruno </a:t>
-            </a:r>
-            <a:r>
-              <a:rPr lang="it-IT" dirty="0">
-                <a:latin typeface="Abadi" panose="020F0502020204030204" pitchFamily="34" charset="0"/>
-              </a:rPr>
-              <a:t>S</a:t>
-            </a:r>
-            <a:r>
-              <a:rPr lang="it-IT" dirty="0"/>
-              <a:t>artini (he/</a:t>
-            </a:r>
-            <a:r>
-              <a:rPr lang="it-IT" dirty="0" err="1"/>
-              <a:t>him</a:t>
-            </a:r>
-            <a:r>
-              <a:rPr lang="it-IT" dirty="0"/>
-              <a:t>)</a:t>
-            </a:r>
-          </a:p>
-          <a:p>
-            <a:r>
-              <a:rPr lang="it-IT" dirty="0"/>
-              <a:t>b.sartini@lmu.de</a:t>
+              <a:t>Dr. Evan Eames</a:t>
+            </a:r>
+          </a:p>
+          <a:p>
+            <a:r>
+              <a:rPr lang="it-IT"/>
+              <a:t>evan.eames@</a:t>
+            </a:r>
+            <a:r>
+              <a:rPr lang="it-IT" dirty="0"/>
+              <a:t>lmu.de</a:t>
             </a:r>
             <a:endParaRPr lang="en-US" dirty="0"/>
           </a:p>
@@ -4933,7 +4924,7 @@
         <p:spPr/>
         <p:txBody>
           <a:bodyPr>
-            <a:normAutofit fontScale="92500" lnSpcReduction="10000"/>
+            <a:normAutofit fontScale="92500"/>
           </a:bodyPr>
           <a:lstStyle/>
           <a:p>
@@ -4979,23 +4970,7 @@
                   <a:srgbClr val="FFFF00"/>
                 </a:highlight>
               </a:rPr>
-              <a:t> 13 </a:t>
-            </a:r>
-            <a:r>
-              <a:rPr lang="it-IT" dirty="0" err="1">
-                <a:highlight>
-                  <a:srgbClr val="FFFF00"/>
-                </a:highlight>
-              </a:rPr>
-              <a:t>th</a:t>
-            </a:r>
-            <a:r>
-              <a:rPr lang="it-IT" dirty="0">
-                <a:highlight>
-                  <a:srgbClr val="FFFF00"/>
-                </a:highlight>
-              </a:rPr>
-              <a:t>&lt; </a:t>
+              <a:t> 10th&lt; </a:t>
             </a:r>
             <a:r>
               <a:rPr lang="it-IT" dirty="0" err="1"/>
@@ -5066,24 +5041,20 @@
           </a:p>
           <a:p>
             <a:r>
-              <a:rPr lang="it-IT" dirty="0"/>
-              <a:t>The </a:t>
-            </a:r>
-            <a:r>
-              <a:rPr lang="it-IT" dirty="0" err="1"/>
-              <a:t>exam</a:t>
-            </a:r>
-            <a:r>
-              <a:rPr lang="it-IT" dirty="0"/>
-              <a:t> can be done in 90 minutes. If needed I can give </a:t>
-            </a:r>
-            <a:r>
-              <a:rPr lang="it-IT" dirty="0" err="1"/>
-              <a:t>you</a:t>
-            </a:r>
-            <a:r>
-              <a:rPr lang="it-IT" dirty="0"/>
-              <a:t> max 120 minutes. So, </a:t>
+              <a:rPr lang="it-IT" dirty="0" err="1"/>
+              <a:t>You</a:t>
+            </a:r>
+            <a:r>
+              <a:rPr lang="it-IT" dirty="0"/>
+              <a:t> </a:t>
+            </a:r>
+            <a:r>
+              <a:rPr lang="it-IT" dirty="0" err="1"/>
+              <a:t>get</a:t>
+            </a:r>
+            <a:r>
+              <a:rPr lang="it-IT" dirty="0"/>
+              <a:t> 120 minutes. So, </a:t>
             </a:r>
             <a:r>
               <a:rPr lang="it-IT" dirty="0" err="1"/>

</xml_diff>